<commit_message>
correction namespaces monadic ⎕NS returns scalar ref
</commit_message>
<xml_diff>
--- a/slides/APL_Bootcamp-part-8-namespaces.pptx
+++ b/slides/APL_Bootcamp-part-8-namespaces.pptx
@@ -287,7 +287,7 @@
               <a:rPr lang="en-GB" smtClean="0">
                 <a:latin typeface="Sarabun" panose="00000500000000000000" pitchFamily="2" charset="-34"/>
               </a:rPr>
-              <a:t>10/08/2025</a:t>
+              <a:t>11/09/2025</a:t>
             </a:fld>
             <a:endParaRPr lang="en-GB" dirty="0">
               <a:latin typeface="Sarabun" panose="00000500000000000000" pitchFamily="2" charset="-34"/>
@@ -465,7 +465,7 @@
             <a:fld id="{CDEAEF8A-5BB8-41C8-B8C2-160617C17EF4}" type="datetimeFigureOut">
               <a:rPr lang="en-GB" smtClean="0"/>
               <a:pPr/>
-              <a:t>10/08/2025</a:t>
+              <a:t>11/09/2025</a:t>
             </a:fld>
             <a:endParaRPr lang="en-GB" dirty="0"/>
           </a:p>
@@ -11372,10 +11372,16 @@
               <a:buNone/>
             </a:pPr>
             <a:r>
-              <a:rPr lang="en-GB" dirty="0">
-                <a:latin typeface="APL385 Unicode" panose="020B0709000202000203" pitchFamily="49" charset="0"/>
-              </a:rPr>
-              <a:t>#.[Namespace]</a:t>
+              <a:rPr lang="en-GB">
+                <a:latin typeface="APL385 Unicode" panose="020B0709000202000203" pitchFamily="49" charset="0"/>
+              </a:rPr>
+              <a:t>#.[Namespace</a:t>
+            </a:r>
+            <a:r>
+              <a:rPr lang="en-GB" dirty="0">
+                <a:latin typeface="APL385 Unicode" panose="020B0709000202000203" pitchFamily="49" charset="0"/>
+              </a:rPr>
+              <a:t>]</a:t>
             </a:r>
           </a:p>
           <a:p>
@@ -11451,7 +11457,7 @@
             </a:pPr>
             <a:r>
               <a:rPr lang="en-GB" dirty="0"/>
-              <a:t>The result of dyadic </a:t>
+              <a:t>The result of monadic </a:t>
             </a:r>
             <a:r>
               <a:rPr lang="en-GB" dirty="0">

</xml_diff>